<commit_message>
Add Jesse Perez to presentation and split transcript three ways
</commit_message>
<xml_diff>
--- a/PipeRewind_Presentation.pptx
+++ b/PipeRewind_Presentation.pptx
@@ -3263,7 +3263,7 @@
               </a:defRPr>
             </a:pPr>
             <a:r>
-              <a:t>Luiz Takahashi  &amp;  Ehzoc Chavez</a:t>
+              <a:t>Luiz Takahashi, Ehzoc Chavez, &amp; Jesse Perez</a:t>
             </a:r>
           </a:p>
         </p:txBody>
@@ -8368,7 +8368,7 @@
               </a:defRPr>
             </a:pPr>
             <a:r>
-              <a:t>Luiz Takahashi  &amp;  Ehzoc Chavez</a:t>
+              <a:t>Luiz Takahashi, Ehzoc Chavez, &amp; Jesse Perez</a:t>
             </a:r>
           </a:p>
         </p:txBody>

</xml_diff>